<commit_message>
Moved W9S1 lecture ahead.
</commit_message>
<xml_diff>
--- a/W8/W8S2 - Token2/W8S2.pptx
+++ b/W8/W8S2 - Token2/W8S2.pptx
@@ -294,8 +294,8 @@
 <pc:chgInfo xmlns:a="http://schemas.openxmlformats.org/drawingml/2006/main" xmlns:r="http://schemas.openxmlformats.org/officeDocument/2006/relationships" xmlns:ac="http://schemas.microsoft.com/office/drawing/2013/main/command" xmlns:pc="http://schemas.microsoft.com/office/powerpoint/2013/main/command">
   <pc:docChgLst>
     <pc:chgData name="Matthieu De Mari" userId="dfb708c9-d8dc-439f-9a3b-c772bf4a311c" providerId="ADAL" clId="{81E9B007-0C2C-493E-9B93-55A62C9C1F12}"/>
-    <pc:docChg chg="modSld">
-      <pc:chgData name="Matthieu De Mari" userId="dfb708c9-d8dc-439f-9a3b-c772bf4a311c" providerId="ADAL" clId="{81E9B007-0C2C-493E-9B93-55A62C9C1F12}" dt="2026-03-03T10:09:39.552" v="1" actId="20577"/>
+    <pc:docChg chg="custSel modSld">
+      <pc:chgData name="Matthieu De Mari" userId="dfb708c9-d8dc-439f-9a3b-c772bf4a311c" providerId="ADAL" clId="{81E9B007-0C2C-493E-9B93-55A62C9C1F12}" dt="2026-03-16T03:56:01.997" v="186" actId="313"/>
       <pc:docMkLst>
         <pc:docMk/>
       </pc:docMkLst>
@@ -311,6 +311,21 @@
             <pc:docMk/>
             <pc:sldMk cId="1040156172" sldId="377"/>
             <ac:spMk id="2" creationId="{080CEB46-CC16-4D19-8C2C-AEE9471D8168}"/>
+          </ac:spMkLst>
+        </pc:spChg>
+      </pc:sldChg>
+      <pc:sldChg chg="modSp mod">
+        <pc:chgData name="Matthieu De Mari" userId="dfb708c9-d8dc-439f-9a3b-c772bf4a311c" providerId="ADAL" clId="{81E9B007-0C2C-493E-9B93-55A62C9C1F12}" dt="2026-03-16T03:56:01.997" v="186" actId="313"/>
+        <pc:sldMkLst>
+          <pc:docMk/>
+          <pc:sldMk cId="550687034" sldId="442"/>
+        </pc:sldMkLst>
+        <pc:spChg chg="mod">
+          <ac:chgData name="Matthieu De Mari" userId="dfb708c9-d8dc-439f-9a3b-c772bf4a311c" providerId="ADAL" clId="{81E9B007-0C2C-493E-9B93-55A62C9C1F12}" dt="2026-03-16T03:56:01.997" v="186" actId="313"/>
+          <ac:spMkLst>
+            <pc:docMk/>
+            <pc:sldMk cId="550687034" sldId="442"/>
+            <ac:spMk id="3" creationId="{7A49F8E6-763D-7142-F585-7B1ABD5BE5DE}"/>
           </ac:spMkLst>
         </pc:spChg>
       </pc:sldChg>
@@ -401,7 +416,7 @@
           <a:p>
             <a:fld id="{98CFC6A4-B085-437B-8084-693BEB2A32DE}" type="datetimeFigureOut">
               <a:rPr lang="en-SG" smtClean="0"/>
-              <a:t>3/3/2026</a:t>
+              <a:t>16/3/2026</a:t>
             </a:fld>
             <a:endParaRPr lang="en-SG"/>
           </a:p>
@@ -818,7 +833,7 @@
           <a:p>
             <a:fld id="{AB35F6B0-D468-4997-9CE3-CF2A1AE5E3F9}" type="datetimeFigureOut">
               <a:rPr lang="en-SG" smtClean="0"/>
-              <a:t>3/3/2026</a:t>
+              <a:t>16/3/2026</a:t>
             </a:fld>
             <a:endParaRPr lang="en-SG"/>
           </a:p>
@@ -1018,7 +1033,7 @@
           <a:p>
             <a:fld id="{AB35F6B0-D468-4997-9CE3-CF2A1AE5E3F9}" type="datetimeFigureOut">
               <a:rPr lang="en-SG" smtClean="0"/>
-              <a:t>3/3/2026</a:t>
+              <a:t>16/3/2026</a:t>
             </a:fld>
             <a:endParaRPr lang="en-SG"/>
           </a:p>
@@ -1228,7 +1243,7 @@
           <a:p>
             <a:fld id="{AB35F6B0-D468-4997-9CE3-CF2A1AE5E3F9}" type="datetimeFigureOut">
               <a:rPr lang="en-SG" smtClean="0"/>
-              <a:t>3/3/2026</a:t>
+              <a:t>16/3/2026</a:t>
             </a:fld>
             <a:endParaRPr lang="en-SG"/>
           </a:p>
@@ -1428,7 +1443,7 @@
           <a:p>
             <a:fld id="{AB35F6B0-D468-4997-9CE3-CF2A1AE5E3F9}" type="datetimeFigureOut">
               <a:rPr lang="en-SG" smtClean="0"/>
-              <a:t>3/3/2026</a:t>
+              <a:t>16/3/2026</a:t>
             </a:fld>
             <a:endParaRPr lang="en-SG"/>
           </a:p>
@@ -1704,7 +1719,7 @@
           <a:p>
             <a:fld id="{AB35F6B0-D468-4997-9CE3-CF2A1AE5E3F9}" type="datetimeFigureOut">
               <a:rPr lang="en-SG" smtClean="0"/>
-              <a:t>3/3/2026</a:t>
+              <a:t>16/3/2026</a:t>
             </a:fld>
             <a:endParaRPr lang="en-SG"/>
           </a:p>
@@ -1972,7 +1987,7 @@
           <a:p>
             <a:fld id="{AB35F6B0-D468-4997-9CE3-CF2A1AE5E3F9}" type="datetimeFigureOut">
               <a:rPr lang="en-SG" smtClean="0"/>
-              <a:t>3/3/2026</a:t>
+              <a:t>16/3/2026</a:t>
             </a:fld>
             <a:endParaRPr lang="en-SG"/>
           </a:p>
@@ -2387,7 +2402,7 @@
           <a:p>
             <a:fld id="{AB35F6B0-D468-4997-9CE3-CF2A1AE5E3F9}" type="datetimeFigureOut">
               <a:rPr lang="en-SG" smtClean="0"/>
-              <a:t>3/3/2026</a:t>
+              <a:t>16/3/2026</a:t>
             </a:fld>
             <a:endParaRPr lang="en-SG"/>
           </a:p>
@@ -2529,7 +2544,7 @@
           <a:p>
             <a:fld id="{AB35F6B0-D468-4997-9CE3-CF2A1AE5E3F9}" type="datetimeFigureOut">
               <a:rPr lang="en-SG" smtClean="0"/>
-              <a:t>3/3/2026</a:t>
+              <a:t>16/3/2026</a:t>
             </a:fld>
             <a:endParaRPr lang="en-SG"/>
           </a:p>
@@ -2642,7 +2657,7 @@
           <a:p>
             <a:fld id="{AB35F6B0-D468-4997-9CE3-CF2A1AE5E3F9}" type="datetimeFigureOut">
               <a:rPr lang="en-SG" smtClean="0"/>
-              <a:t>3/3/2026</a:t>
+              <a:t>16/3/2026</a:t>
             </a:fld>
             <a:endParaRPr lang="en-SG"/>
           </a:p>
@@ -2955,7 +2970,7 @@
           <a:p>
             <a:fld id="{AB35F6B0-D468-4997-9CE3-CF2A1AE5E3F9}" type="datetimeFigureOut">
               <a:rPr lang="en-SG" smtClean="0"/>
-              <a:t>3/3/2026</a:t>
+              <a:t>16/3/2026</a:t>
             </a:fld>
             <a:endParaRPr lang="en-SG"/>
           </a:p>
@@ -3244,7 +3259,7 @@
           <a:p>
             <a:fld id="{AB35F6B0-D468-4997-9CE3-CF2A1AE5E3F9}" type="datetimeFigureOut">
               <a:rPr lang="en-SG" smtClean="0"/>
-              <a:t>3/3/2026</a:t>
+              <a:t>16/3/2026</a:t>
             </a:fld>
             <a:endParaRPr lang="en-SG"/>
           </a:p>
@@ -3487,7 +3502,7 @@
           <a:p>
             <a:fld id="{AB35F6B0-D468-4997-9CE3-CF2A1AE5E3F9}" type="datetimeFigureOut">
               <a:rPr lang="en-SG" smtClean="0"/>
-              <a:t>3/3/2026</a:t>
+              <a:t>16/3/2026</a:t>
             </a:fld>
             <a:endParaRPr lang="en-SG"/>
           </a:p>
@@ -13994,7 +14009,36 @@
             </a:pPr>
             <a:r>
               <a:rPr lang="en-GB" dirty="0"/>
-              <a:t>Can you find out where?</a:t>
+              <a:t>Saw it last year and fixed it at first, but students said it could have been a challenge, so… here it is.</a:t>
+            </a:r>
+          </a:p>
+          <a:p>
+            <a:pPr marL="0" indent="0">
+              <a:buNone/>
+            </a:pPr>
+            <a:r>
+              <a:rPr lang="en-GB"/>
+              <a:t>Find </a:t>
+            </a:r>
+            <a:r>
+              <a:rPr lang="en-GB" dirty="0"/>
+              <a:t>where is the </a:t>
+            </a:r>
+            <a:r>
+              <a:rPr lang="en-GB"/>
+              <a:t>missing “break” </a:t>
+            </a:r>
+            <a:r>
+              <a:rPr lang="en-GB" dirty="0"/>
+              <a:t>in our maximal </a:t>
+            </a:r>
+            <a:r>
+              <a:rPr lang="en-GB"/>
+              <a:t>munch algorithm</a:t>
+            </a:r>
+            <a:r>
+              <a:rPr lang="en-GB" dirty="0"/>
+              <a:t>!</a:t>
             </a:r>
           </a:p>
           <a:p>

</xml_diff>